<commit_message>
Verif Arduino drone Code
</commit_message>
<xml_diff>
--- a/simulateur/Results_stabilization/Results Stabilization Drone.pptx
+++ b/simulateur/Results_stabilization/Results Stabilization Drone.pptx
@@ -8,6 +8,7 @@
     <p:sldId id="256" r:id="rId2"/>
     <p:sldId id="258" r:id="rId3"/>
     <p:sldId id="259" r:id="rId4"/>
+    <p:sldId id="260" r:id="rId5"/>
   </p:sldIdLst>
   <p:sldSz cx="12192000" cy="6858000"/>
   <p:notesSz cx="6858000" cy="9144000"/>
@@ -106,6 +107,11 @@
       </a:defRPr>
     </a:lvl9pPr>
   </p:defaultTextStyle>
+  <p:extLst>
+    <p:ext uri="{EFAFB233-063F-42B5-8137-9DF3F51BA10A}">
+      <p15:sldGuideLst xmlns:p15="http://schemas.microsoft.com/office/powerpoint/2012/main"/>
+    </p:ext>
+  </p:extLst>
 </p:presentation>
 </file>
 
@@ -4852,6 +4858,502 @@
     <p:extLst>
       <p:ext uri="{BB962C8B-B14F-4D97-AF65-F5344CB8AC3E}">
         <p14:creationId xmlns:p14="http://schemas.microsoft.com/office/powerpoint/2010/main" val="2107611495"/>
+      </p:ext>
+    </p:extLst>
+  </p:cSld>
+  <p:clrMapOvr>
+    <a:masterClrMapping/>
+  </p:clrMapOvr>
+</p:sld>
+</file>
+
+<file path=ppt/slides/slide4.xml><?xml version="1.0" encoding="utf-8"?>
+<p:sld xmlns:a="http://schemas.openxmlformats.org/drawingml/2006/main" xmlns:r="http://schemas.openxmlformats.org/officeDocument/2006/relationships" xmlns:p="http://schemas.openxmlformats.org/presentationml/2006/main">
+  <p:cSld>
+    <p:spTree>
+      <p:nvGrpSpPr>
+        <p:cNvPr id="1" name="">
+          <a:extLst>
+            <a:ext uri="{FF2B5EF4-FFF2-40B4-BE49-F238E27FC236}">
+              <a16:creationId xmlns:a16="http://schemas.microsoft.com/office/drawing/2014/main" id="{B895EC3A-610A-23BB-A246-0CD06C273253}"/>
+            </a:ext>
+          </a:extLst>
+        </p:cNvPr>
+        <p:cNvGrpSpPr/>
+        <p:nvPr/>
+      </p:nvGrpSpPr>
+      <p:grpSpPr>
+        <a:xfrm>
+          <a:off x="0" y="0"/>
+          <a:ext cx="0" cy="0"/>
+          <a:chOff x="0" y="0"/>
+          <a:chExt cx="0" cy="0"/>
+        </a:xfrm>
+      </p:grpSpPr>
+      <p:pic>
+        <p:nvPicPr>
+          <p:cNvPr id="6" name="Image 5">
+            <a:extLst>
+              <a:ext uri="{FF2B5EF4-FFF2-40B4-BE49-F238E27FC236}">
+                <a16:creationId xmlns:a16="http://schemas.microsoft.com/office/drawing/2014/main" id="{49D10BD7-18E7-B90F-A4CC-991357D0A56B}"/>
+              </a:ext>
+            </a:extLst>
+          </p:cNvPr>
+          <p:cNvPicPr>
+            <a:picLocks noChangeAspect="1"/>
+          </p:cNvPicPr>
+          <p:nvPr/>
+        </p:nvPicPr>
+        <p:blipFill>
+          <a:blip r:embed="rId2">
+            <a:extLst>
+              <a:ext uri="{28A0092B-C50C-407E-A947-70E740481C1C}">
+                <a14:useLocalDpi xmlns:a14="http://schemas.microsoft.com/office/drawing/2010/main" val="0"/>
+              </a:ext>
+            </a:extLst>
+          </a:blip>
+          <a:srcRect l="2555" t="7493" r="8902"/>
+          <a:stretch>
+            <a:fillRect/>
+          </a:stretch>
+        </p:blipFill>
+        <p:spPr>
+          <a:xfrm>
+            <a:off x="8142427" y="46237"/>
+            <a:ext cx="4049573" cy="3173213"/>
+          </a:xfrm>
+          <a:prstGeom prst="rect">
+            <a:avLst/>
+          </a:prstGeom>
+        </p:spPr>
+      </p:pic>
+      <p:sp>
+        <p:nvSpPr>
+          <p:cNvPr id="2" name="Titre 1">
+            <a:extLst>
+              <a:ext uri="{FF2B5EF4-FFF2-40B4-BE49-F238E27FC236}">
+                <a16:creationId xmlns:a16="http://schemas.microsoft.com/office/drawing/2014/main" id="{910C1856-6C88-8117-D223-53E29B4038E3}"/>
+              </a:ext>
+            </a:extLst>
+          </p:cNvPr>
+          <p:cNvSpPr>
+            <a:spLocks noGrp="1"/>
+          </p:cNvSpPr>
+          <p:nvPr>
+            <p:ph type="title"/>
+          </p:nvPr>
+        </p:nvSpPr>
+        <p:spPr>
+          <a:xfrm>
+            <a:off x="548640" y="856271"/>
+            <a:ext cx="4114800" cy="1645139"/>
+          </a:xfrm>
+        </p:spPr>
+        <p:txBody>
+          <a:bodyPr vert="horz" lIns="91440" tIns="45720" rIns="91440" bIns="45720" rtlCol="0" anchor="b">
+            <a:normAutofit fontScale="90000"/>
+          </a:bodyPr>
+          <a:lstStyle/>
+          <a:p>
+            <a:r>
+              <a:rPr lang="en-US" sz="3800" b="1" dirty="0"/>
+              <a:t>Pitch angle </a:t>
+            </a:r>
+            <a:r>
+              <a:rPr lang="en-US" sz="3800" dirty="0"/>
+              <a:t>stabilization</a:t>
+            </a:r>
+            <a:br>
+              <a:rPr lang="en-US" sz="3800" dirty="0"/>
+            </a:br>
+            <a:r>
+              <a:rPr lang="en-US" sz="3800" dirty="0"/>
+              <a:t>Simulation</a:t>
+            </a:r>
+          </a:p>
+        </p:txBody>
+      </p:sp>
+      <p:sp>
+        <p:nvSpPr>
+          <p:cNvPr id="14" name="Titre 1">
+            <a:extLst>
+              <a:ext uri="{FF2B5EF4-FFF2-40B4-BE49-F238E27FC236}">
+                <a16:creationId xmlns:a16="http://schemas.microsoft.com/office/drawing/2014/main" id="{04396F17-72DE-9738-516E-D863FD4B50CA}"/>
+              </a:ext>
+            </a:extLst>
+          </p:cNvPr>
+          <p:cNvSpPr txBox="1">
+            <a:spLocks/>
+          </p:cNvSpPr>
+          <p:nvPr/>
+        </p:nvSpPr>
+        <p:spPr>
+          <a:xfrm>
+            <a:off x="548640" y="2942520"/>
+            <a:ext cx="3659228" cy="3245804"/>
+          </a:xfrm>
+          <a:prstGeom prst="rect">
+            <a:avLst/>
+          </a:prstGeom>
+        </p:spPr>
+        <p:txBody>
+          <a:bodyPr vert="horz" lIns="91440" tIns="45720" rIns="91440" bIns="45720" rtlCol="0">
+            <a:normAutofit/>
+          </a:bodyPr>
+          <a:lstStyle>
+            <a:lvl1pPr algn="l" defTabSz="914400" rtl="0" eaLnBrk="1" latinLnBrk="0" hangingPunct="1">
+              <a:lnSpc>
+                <a:spcPct val="90000"/>
+              </a:lnSpc>
+              <a:spcBef>
+                <a:spcPct val="0"/>
+              </a:spcBef>
+              <a:buNone/>
+              <a:defRPr sz="4400" kern="1200">
+                <a:solidFill>
+                  <a:schemeClr val="tx1"/>
+                </a:solidFill>
+                <a:latin typeface="+mj-lt"/>
+                <a:ea typeface="+mj-ea"/>
+                <a:cs typeface="+mj-cs"/>
+              </a:defRPr>
+            </a:lvl1pPr>
+          </a:lstStyle>
+          <a:p>
+            <a:pPr indent="-228600">
+              <a:spcAft>
+                <a:spcPts val="600"/>
+              </a:spcAft>
+              <a:buFont typeface="Arial" panose="020B0604020202020204" pitchFamily="34" charset="0"/>
+              <a:buChar char="•"/>
+            </a:pPr>
+            <a:r>
+              <a:rPr lang="en-US" sz="1800" dirty="0">
+                <a:latin typeface="+mn-lt"/>
+                <a:ea typeface="+mn-ea"/>
+                <a:cs typeface="+mn-cs"/>
+              </a:rPr>
+              <a:t>Problem :</a:t>
+            </a:r>
+          </a:p>
+          <a:p>
+            <a:pPr marL="457200" indent="-228600">
+              <a:spcAft>
+                <a:spcPts val="600"/>
+              </a:spcAft>
+              <a:buFont typeface="Arial" panose="020B0604020202020204" pitchFamily="34" charset="0"/>
+              <a:buChar char="•"/>
+            </a:pPr>
+            <a:r>
+              <a:rPr lang="en-US" sz="1800" dirty="0">
+                <a:latin typeface="+mn-lt"/>
+                <a:ea typeface="+mn-ea"/>
+                <a:cs typeface="+mn-cs"/>
+              </a:rPr>
+              <a:t>Low angle (5 and 10 deg) : angle command exceeded</a:t>
+            </a:r>
+          </a:p>
+        </p:txBody>
+      </p:sp>
+      <p:graphicFrame>
+        <p:nvGraphicFramePr>
+          <p:cNvPr id="27" name="Tableau 26">
+            <a:extLst>
+              <a:ext uri="{FF2B5EF4-FFF2-40B4-BE49-F238E27FC236}">
+                <a16:creationId xmlns:a16="http://schemas.microsoft.com/office/drawing/2014/main" id="{30E7ED2D-3C24-9B6D-CA70-76E4D1FF85B7}"/>
+              </a:ext>
+            </a:extLst>
+          </p:cNvPr>
+          <p:cNvGraphicFramePr>
+            <a:graphicFrameLocks noGrp="1"/>
+          </p:cNvGraphicFramePr>
+          <p:nvPr>
+            <p:extLst>
+              <p:ext uri="{D42A27DB-BD31-4B8C-83A1-F6EECF244321}">
+                <p14:modId xmlns:p14="http://schemas.microsoft.com/office/powerpoint/2010/main" val="4244079769"/>
+              </p:ext>
+            </p:extLst>
+          </p:nvPr>
+        </p:nvGraphicFramePr>
+        <p:xfrm>
+          <a:off x="599906" y="4518369"/>
+          <a:ext cx="3189224" cy="1483360"/>
+        </p:xfrm>
+        <a:graphic>
+          <a:graphicData uri="http://schemas.openxmlformats.org/drawingml/2006/table">
+            <a:tbl>
+              <a:tblPr firstRow="1" bandRow="1">
+                <a:tableStyleId>{5C22544A-7EE6-4342-B048-85BDC9FD1C3A}</a:tableStyleId>
+              </a:tblPr>
+              <a:tblGrid>
+                <a:gridCol w="1594612">
+                  <a:extLst>
+                    <a:ext uri="{9D8B030D-6E8A-4147-A177-3AD203B41FA5}">
+                      <a16:colId xmlns:a16="http://schemas.microsoft.com/office/drawing/2014/main" val="947051945"/>
+                    </a:ext>
+                  </a:extLst>
+                </a:gridCol>
+                <a:gridCol w="1594612">
+                  <a:extLst>
+                    <a:ext uri="{9D8B030D-6E8A-4147-A177-3AD203B41FA5}">
+                      <a16:colId xmlns:a16="http://schemas.microsoft.com/office/drawing/2014/main" val="2559176574"/>
+                    </a:ext>
+                  </a:extLst>
+                </a:gridCol>
+              </a:tblGrid>
+              <a:tr h="370840">
+                <a:tc>
+                  <a:txBody>
+                    <a:bodyPr/>
+                    <a:lstStyle/>
+                    <a:p>
+                      <a:r>
+                        <a:rPr lang="fr-FR" dirty="0"/>
+                        <a:t>Coefficient</a:t>
+                      </a:r>
+                    </a:p>
+                  </a:txBody>
+                  <a:tcPr/>
+                </a:tc>
+                <a:tc>
+                  <a:txBody>
+                    <a:bodyPr/>
+                    <a:lstStyle/>
+                    <a:p>
+                      <a:r>
+                        <a:rPr lang="fr-FR" dirty="0"/>
+                        <a:t>Values</a:t>
+                      </a:r>
+                    </a:p>
+                  </a:txBody>
+                  <a:tcPr/>
+                </a:tc>
+                <a:extLst>
+                  <a:ext uri="{0D108BD9-81ED-4DB2-BD59-A6C34878D82A}">
+                    <a16:rowId xmlns:a16="http://schemas.microsoft.com/office/drawing/2014/main" val="1696961107"/>
+                  </a:ext>
+                </a:extLst>
+              </a:tr>
+              <a:tr h="370840">
+                <a:tc>
+                  <a:txBody>
+                    <a:bodyPr/>
+                    <a:lstStyle/>
+                    <a:p>
+                      <a:r>
+                        <a:rPr lang="fr-FR" dirty="0" err="1"/>
+                        <a:t>Kp</a:t>
+                      </a:r>
+                      <a:endParaRPr lang="fr-FR" dirty="0"/>
+                    </a:p>
+                  </a:txBody>
+                  <a:tcPr/>
+                </a:tc>
+                <a:tc>
+                  <a:txBody>
+                    <a:bodyPr/>
+                    <a:lstStyle/>
+                    <a:p>
+                      <a:r>
+                        <a:rPr lang="fr-FR" dirty="0"/>
+                        <a:t>80,0</a:t>
+                      </a:r>
+                    </a:p>
+                  </a:txBody>
+                  <a:tcPr/>
+                </a:tc>
+                <a:extLst>
+                  <a:ext uri="{0D108BD9-81ED-4DB2-BD59-A6C34878D82A}">
+                    <a16:rowId xmlns:a16="http://schemas.microsoft.com/office/drawing/2014/main" val="1425156382"/>
+                  </a:ext>
+                </a:extLst>
+              </a:tr>
+              <a:tr h="370840">
+                <a:tc>
+                  <a:txBody>
+                    <a:bodyPr/>
+                    <a:lstStyle/>
+                    <a:p>
+                      <a:r>
+                        <a:rPr lang="fr-FR" dirty="0"/>
+                        <a:t>Ki</a:t>
+                      </a:r>
+                    </a:p>
+                  </a:txBody>
+                  <a:tcPr/>
+                </a:tc>
+                <a:tc>
+                  <a:txBody>
+                    <a:bodyPr/>
+                    <a:lstStyle/>
+                    <a:p>
+                      <a:r>
+                        <a:rPr lang="fr-FR" dirty="0"/>
+                        <a:t>0,8</a:t>
+                      </a:r>
+                    </a:p>
+                  </a:txBody>
+                  <a:tcPr/>
+                </a:tc>
+                <a:extLst>
+                  <a:ext uri="{0D108BD9-81ED-4DB2-BD59-A6C34878D82A}">
+                    <a16:rowId xmlns:a16="http://schemas.microsoft.com/office/drawing/2014/main" val="103946773"/>
+                  </a:ext>
+                </a:extLst>
+              </a:tr>
+              <a:tr h="370840">
+                <a:tc>
+                  <a:txBody>
+                    <a:bodyPr/>
+                    <a:lstStyle/>
+                    <a:p>
+                      <a:r>
+                        <a:rPr lang="fr-FR" dirty="0" err="1"/>
+                        <a:t>Kd</a:t>
+                      </a:r>
+                      <a:endParaRPr lang="fr-FR" dirty="0"/>
+                    </a:p>
+                  </a:txBody>
+                  <a:tcPr/>
+                </a:tc>
+                <a:tc>
+                  <a:txBody>
+                    <a:bodyPr/>
+                    <a:lstStyle/>
+                    <a:p>
+                      <a:r>
+                        <a:rPr lang="fr-FR" dirty="0"/>
+                        <a:t>19,0</a:t>
+                      </a:r>
+                    </a:p>
+                  </a:txBody>
+                  <a:tcPr/>
+                </a:tc>
+                <a:extLst>
+                  <a:ext uri="{0D108BD9-81ED-4DB2-BD59-A6C34878D82A}">
+                    <a16:rowId xmlns:a16="http://schemas.microsoft.com/office/drawing/2014/main" val="3790116837"/>
+                  </a:ext>
+                </a:extLst>
+              </a:tr>
+            </a:tbl>
+          </a:graphicData>
+        </a:graphic>
+      </p:graphicFrame>
+      <p:pic>
+        <p:nvPicPr>
+          <p:cNvPr id="4" name="Image 3">
+            <a:extLst>
+              <a:ext uri="{FF2B5EF4-FFF2-40B4-BE49-F238E27FC236}">
+                <a16:creationId xmlns:a16="http://schemas.microsoft.com/office/drawing/2014/main" id="{D33ABCAD-DF11-CE13-9423-DB7038C274B7}"/>
+              </a:ext>
+            </a:extLst>
+          </p:cNvPr>
+          <p:cNvPicPr>
+            <a:picLocks noChangeAspect="1"/>
+          </p:cNvPicPr>
+          <p:nvPr/>
+        </p:nvPicPr>
+        <p:blipFill>
+          <a:blip r:embed="rId3">
+            <a:extLst>
+              <a:ext uri="{28A0092B-C50C-407E-A947-70E740481C1C}">
+                <a14:useLocalDpi xmlns:a14="http://schemas.microsoft.com/office/drawing/2010/main" val="0"/>
+              </a:ext>
+            </a:extLst>
+          </a:blip>
+          <a:srcRect l="4209" t="6621" r="9504"/>
+          <a:stretch>
+            <a:fillRect/>
+          </a:stretch>
+        </p:blipFill>
+        <p:spPr>
+          <a:xfrm>
+            <a:off x="4190362" y="83075"/>
+            <a:ext cx="3909594" cy="3173213"/>
+          </a:xfrm>
+          <a:prstGeom prst="rect">
+            <a:avLst/>
+          </a:prstGeom>
+        </p:spPr>
+      </p:pic>
+      <p:pic>
+        <p:nvPicPr>
+          <p:cNvPr id="8" name="Image 7">
+            <a:extLst>
+              <a:ext uri="{FF2B5EF4-FFF2-40B4-BE49-F238E27FC236}">
+                <a16:creationId xmlns:a16="http://schemas.microsoft.com/office/drawing/2014/main" id="{97A625CA-3517-AAC7-BFCB-607BBA635115}"/>
+              </a:ext>
+            </a:extLst>
+          </p:cNvPr>
+          <p:cNvPicPr>
+            <a:picLocks noChangeAspect="1"/>
+          </p:cNvPicPr>
+          <p:nvPr/>
+        </p:nvPicPr>
+        <p:blipFill>
+          <a:blip r:embed="rId4">
+            <a:extLst>
+              <a:ext uri="{28A0092B-C50C-407E-A947-70E740481C1C}">
+                <a14:useLocalDpi xmlns:a14="http://schemas.microsoft.com/office/drawing/2010/main" val="0"/>
+              </a:ext>
+            </a:extLst>
+          </a:blip>
+          <a:srcRect l="2799" t="6598" r="9310"/>
+          <a:stretch>
+            <a:fillRect/>
+          </a:stretch>
+        </p:blipFill>
+        <p:spPr>
+          <a:xfrm>
+            <a:off x="4027622" y="3428251"/>
+            <a:ext cx="4072333" cy="3245804"/>
+          </a:xfrm>
+          <a:prstGeom prst="rect">
+            <a:avLst/>
+          </a:prstGeom>
+        </p:spPr>
+      </p:pic>
+      <p:pic>
+        <p:nvPicPr>
+          <p:cNvPr id="10" name="Image 9">
+            <a:extLst>
+              <a:ext uri="{FF2B5EF4-FFF2-40B4-BE49-F238E27FC236}">
+                <a16:creationId xmlns:a16="http://schemas.microsoft.com/office/drawing/2014/main" id="{83B1FA4B-C889-AC5D-FE13-0B0ED1D0B6FE}"/>
+              </a:ext>
+            </a:extLst>
+          </p:cNvPr>
+          <p:cNvPicPr>
+            <a:picLocks noChangeAspect="1"/>
+          </p:cNvPicPr>
+          <p:nvPr/>
+        </p:nvPicPr>
+        <p:blipFill>
+          <a:blip r:embed="rId5">
+            <a:extLst>
+              <a:ext uri="{28A0092B-C50C-407E-A947-70E740481C1C}">
+                <a14:useLocalDpi xmlns:a14="http://schemas.microsoft.com/office/drawing/2010/main" val="0"/>
+              </a:ext>
+            </a:extLst>
+          </a:blip>
+          <a:srcRect l="2474" t="6381" r="8985"/>
+          <a:stretch>
+            <a:fillRect/>
+          </a:stretch>
+        </p:blipFill>
+        <p:spPr>
+          <a:xfrm>
+            <a:off x="8099955" y="3429000"/>
+            <a:ext cx="4092045" cy="3245055"/>
+          </a:xfrm>
+          <a:prstGeom prst="rect">
+            <a:avLst/>
+          </a:prstGeom>
+        </p:spPr>
+      </p:pic>
+    </p:spTree>
+    <p:extLst>
+      <p:ext uri="{BB962C8B-B14F-4D97-AF65-F5344CB8AC3E}">
+        <p14:creationId xmlns:p14="http://schemas.microsoft.com/office/powerpoint/2010/main" val="3359809051"/>
       </p:ext>
     </p:extLst>
   </p:cSld>

</xml_diff>